<commit_message>
Mark Impulsión Falabella active from 11 Aug 2026 in PA fichas
MAM ficha now treats 000025-09 as an operating point (OC/equipment
change), with first-days volumes and night profile. The 7 Malls PPT
is unchanged.

Co-authored-by: anibaloperacionesWes <anibaloperacionesWes@users.noreply.github.com>
</commit_message>
<xml_diff>
--- a/reports/Parque_Arauco/TMP_7MALLS/entrega_diego_anibal/Fichas_ejecutivas_Parque_Arauco_20260814.pptx
+++ b/reports/Parque_Arauco/TMP_7MALLS/entrega_diego_anibal/Fichas_ejecutivas_Parque_Arauco_20260814.pptx
@@ -3827,7 +3827,7 @@
                         </a:defRPr>
                       </a:pPr>
                       <a:r>
-                        <a:t>1.323</a:t>
+                        <a:t>1.377</a:t>
                       </a:r>
                     </a:p>
                   </a:txBody>
@@ -3851,7 +3851,7 @@
                         </a:defRPr>
                       </a:pPr>
                       <a:r>
-                        <a:t>94,5</a:t>
+                        <a:t>98,3</a:t>
                       </a:r>
                     </a:p>
                   </a:txBody>
@@ -3925,7 +3925,7 @@
                         </a:defRPr>
                       </a:pPr>
                       <a:r>
-                        <a:t>4</a:t>
+                        <a:t>5</a:t>
                       </a:r>
                     </a:p>
                   </a:txBody>
@@ -3997,7 +3997,7 @@
                         </a:defRPr>
                       </a:pPr>
                       <a:r>
-                        <a:t>3.288</a:t>
+                        <a:t>3.584</a:t>
                       </a:r>
                     </a:p>
                   </a:txBody>
@@ -4021,7 +4021,7 @@
                         </a:defRPr>
                       </a:pPr>
                       <a:r>
-                        <a:t>234,9</a:t>
+                        <a:t>256</a:t>
                       </a:r>
                     </a:p>
                   </a:txBody>
@@ -4045,7 +4045,7 @@
                         </a:defRPr>
                       </a:pPr>
                       <a:r>
-                        <a:t>Placa se revirtió en ago. Confirmar OC Falabella (dato 11/08).</a:t>
+                        <a:t>Placa se revirtió en ago. Falabella activa desde 11/08.</a:t>
                       </a:r>
                     </a:p>
                   </a:txBody>
@@ -4167,7 +4167,7 @@
                         </a:defRPr>
                       </a:pPr>
                       <a:r>
-                        <a:t>2.774</a:t>
+                        <a:t>2.901</a:t>
                       </a:r>
                     </a:p>
                   </a:txBody>
@@ -4191,7 +4191,7 @@
                         </a:defRPr>
                       </a:pPr>
                       <a:r>
-                        <a:t>198,1</a:t>
+                        <a:t>207,2</a:t>
                       </a:r>
                     </a:p>
                   </a:txBody>
@@ -4337,7 +4337,7 @@
                         </a:defRPr>
                       </a:pPr>
                       <a:r>
-                        <a:t>2.100</a:t>
+                        <a:t>2.181</a:t>
                       </a:r>
                     </a:p>
                   </a:txBody>
@@ -4361,7 +4361,7 @@
                         </a:defRPr>
                       </a:pPr>
                       <a:r>
-                        <a:t>150</a:t>
+                        <a:t>155,8</a:t>
                       </a:r>
                     </a:p>
                   </a:txBody>
@@ -4507,7 +4507,7 @@
                         </a:defRPr>
                       </a:pPr>
                       <a:r>
-                        <a:t>968</a:t>
+                        <a:t>1.005</a:t>
                       </a:r>
                     </a:p>
                   </a:txBody>
@@ -4531,7 +4531,7 @@
                         </a:defRPr>
                       </a:pPr>
                       <a:r>
-                        <a:t>69,2</a:t>
+                        <a:t>71,8</a:t>
                       </a:r>
                     </a:p>
                   </a:txBody>
@@ -4677,7 +4677,7 @@
                         </a:defRPr>
                       </a:pPr>
                       <a:r>
-                        <a:t>294</a:t>
+                        <a:t>304</a:t>
                       </a:r>
                     </a:p>
                   </a:txBody>
@@ -4701,7 +4701,7 @@
                         </a:defRPr>
                       </a:pPr>
                       <a:r>
-                        <a:t>21</a:t>
+                        <a:t>21,7</a:t>
                       </a:r>
                     </a:p>
                   </a:txBody>
@@ -4847,7 +4847,7 @@
                         </a:defRPr>
                       </a:pPr>
                       <a:r>
-                        <a:t>17.265</a:t>
+                        <a:t>17.879</a:t>
                       </a:r>
                     </a:p>
                   </a:txBody>
@@ -4871,7 +4871,7 @@
                         </a:defRPr>
                       </a:pPr>
                       <a:r>
-                        <a:t>1.233,2</a:t>
+                        <a:t>1.277,1</a:t>
                       </a:r>
                     </a:p>
                   </a:txBody>
@@ -5273,7 +5273,7 @@
                 </a:solidFill>
                 <a:latin typeface="Calibri"/>
               </a:rPr>
-              <a:t>Puntos WES activos del recinto. Se excluyen relocalizados en cero (Red de Incendio, Matriz/Baños CUR antiguos, Baños 5/6 PAK, KFC/Poniente 7/Locales comida). Falabella se declara pendiente de OC.</a:t>
+              <a:t>Puntos WES activos del recinto. Se excluyen relocalizados en cero (Red de Incendio, Matriz/Baños CUR antiguos, Baños 5/6 PAK, KFC/Poniente 7/Locales comida). Impulsión Falabella (MAM) quedó activa el 11/08/2026.</a:t>
             </a:r>
           </a:p>
         </p:txBody>
@@ -6313,7 +6313,7 @@
                 </a:solidFill>
                 <a:latin typeface="Calibri"/>
               </a:rPr>
-              <a:t>Agosto 1–14: 1.322,9 m³  (94,5 m³/día)</a:t>
+              <a:t>Agosto 1–14: 1.376,9 m³  (98,3 m³/día)</a:t>
             </a:r>
           </a:p>
           <a:p>
@@ -6329,7 +6329,7 @@
                 </a:solidFill>
                 <a:latin typeface="Calibri"/>
               </a:rPr>
-              <a:t>Proyección agosto: 2.929,3 m³</a:t>
+              <a:t>Proyección agosto: 3.048,8 m³</a:t>
             </a:r>
           </a:p>
           <a:p>
@@ -6345,7 +6345,7 @@
                 </a:solidFill>
                 <a:latin typeface="Calibri"/>
               </a:rPr>
-              <a:t>Mayor aporte: Sala de Bomba Estanque Sur — jun 1.365,2 / jul 801,9 / ago 411 m³</a:t>
+              <a:t>Mayor aporte: Sala de Bomba Estanque Sur — jun 1.365,2 / jul 801,9 / ago 431,8 m³</a:t>
             </a:r>
           </a:p>
           <a:p>
@@ -6361,7 +6361,23 @@
                 </a:solidFill>
                 <a:latin typeface="Calibri"/>
               </a:rPr>
-              <a:t>Variación m³/día: jul vs jun -6%  ·  ago vs jul -5%</a:t>
+              <a:t>Variación m³/día: jul vs jun -6%  ·  ago vs jul -1%</a:t>
+            </a:r>
+          </a:p>
+          <a:p>
+            <a:pPr algn="l">
+              <a:spcAft>
+                <a:spcPts val="200"/>
+              </a:spcAft>
+            </a:pPr>
+            <a:r>
+              <a:rPr sz="1100" b="0">
+                <a:solidFill>
+                  <a:srgbClr val="0D3B66"/>
+                </a:solidFill>
+                <a:latin typeface="Calibri"/>
+              </a:rPr>
+              <a:t>Suma de los 4 puntos del deck (sin 000025-02).</a:t>
             </a:r>
           </a:p>
         </p:txBody>
@@ -7106,7 +7122,7 @@
                 </a:solidFill>
                 <a:latin typeface="Calibri"/>
               </a:rPr>
-              <a:t>4 puntos activos + 1 pendiente OC   |   01/06/2026 – 14/08/2026   |   Recepción 06/11/2025</a:t>
+              <a:t>5 puntos activos   |   01/06/2026 – 14/08/2026   |   Recepción 06/11/2025</a:t>
             </a:r>
           </a:p>
         </p:txBody>
@@ -7245,6 +7261,22 @@
                 </a:solidFill>
                 <a:latin typeface="Calibri"/>
               </a:rPr>
+              <a:t>• Impulsión Falabella (000025-09) — activo desde 11/08/2026 (OC / cambio de equipo)</a:t>
+            </a:r>
+          </a:p>
+          <a:p>
+            <a:pPr algn="l">
+              <a:spcAft>
+                <a:spcPts val="200"/>
+              </a:spcAft>
+            </a:pPr>
+            <a:r>
+              <a:rPr sz="1100" b="0">
+                <a:solidFill>
+                  <a:srgbClr val="0D3B66"/>
+                </a:solidFill>
+                <a:latin typeface="Calibri"/>
+              </a:rPr>
               <a:t>• Impulsión Ripley (000025-10)</a:t>
             </a:r>
           </a:p>
@@ -7278,22 +7310,6 @@
                 <a:latin typeface="Calibri"/>
               </a:rPr>
               <a:t>• Salida de emergencia pasillo 1 ARROW (000025-33)</a:t>
-            </a:r>
-          </a:p>
-          <a:p>
-            <a:pPr algn="l">
-              <a:spcAft>
-                <a:spcPts val="200"/>
-              </a:spcAft>
-            </a:pPr>
-            <a:r>
-              <a:rPr sz="1100" b="0">
-                <a:solidFill>
-                  <a:srgbClr val="0D3B66"/>
-                </a:solidFill>
-                <a:latin typeface="Calibri"/>
-              </a:rPr>
-              <a:t>• Impulsión Falabella (000025-09) — pendiente OC; 4 día(s) con dato en agosto</a:t>
             </a:r>
           </a:p>
         </p:txBody>
@@ -7448,7 +7464,7 @@
                 </a:solidFill>
                 <a:latin typeface="Calibri"/>
               </a:rPr>
-              <a:t>Agosto 1–14: 3.288,5 m³  (234,9 m³/día)</a:t>
+              <a:t>Agosto 1–14: 3.583,8 m³  (256 m³/día)</a:t>
             </a:r>
           </a:p>
           <a:p>
@@ -7464,7 +7480,7 @@
                 </a:solidFill>
                 <a:latin typeface="Calibri"/>
               </a:rPr>
-              <a:t>Proyección agosto: 7.281,6 m³</a:t>
+              <a:t>Proyección agosto: 7.935,5 m³</a:t>
             </a:r>
           </a:p>
           <a:p>
@@ -7480,7 +7496,7 @@
                 </a:solidFill>
                 <a:latin typeface="Calibri"/>
               </a:rPr>
-              <a:t>Mayor aporte: Placa Bancaria — jun 7.241,6 / jul 7.083,9 / ago 1.918,3 m³</a:t>
+              <a:t>Mayor aporte: Placa Bancaria — jun 7.241,6 / jul 7.083,9 / ago 1.972,1 m³</a:t>
             </a:r>
           </a:p>
           <a:p>
@@ -7496,7 +7512,7 @@
                 </a:solidFill>
                 <a:latin typeface="Calibri"/>
               </a:rPr>
-              <a:t>Variación m³/día: jul vs jun 0%  ·  ago vs jul -30%</a:t>
+              <a:t>Variación m³/día: jul vs jun 0%  ·  ago vs jul -23%</a:t>
             </a:r>
           </a:p>
         </p:txBody>
@@ -7643,7 +7659,7 @@
                 </a:solidFill>
                 <a:latin typeface="Calibri"/>
               </a:rPr>
-              <a:t>• Placa Bancaria concentra ~69% del volumen monitoreado.</a:t>
+              <a:t>• Placa Bancaria concentra ~68% del volumen monitoreado (jun–ago).</a:t>
             </a:r>
           </a:p>
           <a:p>
@@ -7707,7 +7723,7 @@
                 </a:solidFill>
                 <a:latin typeface="Calibri"/>
               </a:rPr>
-              <a:t>• Impulsión Falabella: sin dato jun–jul (OC pendiente). Aparecen 4 días desde el 11/08 (24,6 / 55,3 / 66,1 / 12,0 m³) — posible rehabilitación, no consolidada.</a:t>
+              <a:t>• Impulsión Falabella (000025-09) ACTIVA desde el 11/08/2026. Jun–jul = 0 (equipo fuera). 11/08 puesta en marcha 24,6 m³ (día parcial). 12–14/08: 55,3 / 66,1 / 24,1 m³. 15–16/08: 120,5 y 112,1 m³/día. Noche 12/08 7,9 m³ y 13/08 13,1 m³ (0–6 h). Sin control; baseline 2–3 semanas.</a:t>
             </a:r>
           </a:p>
         </p:txBody>
@@ -7830,7 +7846,23 @@
                 </a:solidFill>
                 <a:latin typeface="Calibri"/>
               </a:rPr>
-              <a:t>• Confirmar si la OC / cambio de equipo de Impulsión Falabella ya se ejecutó (hay registros desde el 11/08).</a:t>
+              <a:t>• Incorporar Impulsión Falabella al tablero diario: ya no está en espera de OC; activo desde el 11/08.</a:t>
+            </a:r>
+          </a:p>
+          <a:p>
+            <a:pPr algn="l">
+              <a:spcAft>
+                <a:spcPts val="200"/>
+              </a:spcAft>
+            </a:pPr>
+            <a:r>
+              <a:rPr sz="1000" b="0">
+                <a:solidFill>
+                  <a:srgbClr val="0D3B66"/>
+                </a:solidFill>
+                <a:latin typeface="Calibri"/>
+              </a:rPr>
+              <a:t>• No comparar Falabella con junio–julio (serie en cero). Seguir 2–3 semanas para fijar baseline diurno y nocturno.</a:t>
             </a:r>
           </a:p>
           <a:p>
@@ -8004,6 +8036,22 @@
                 <a:latin typeface="Calibri"/>
               </a:rPr>
               <a:t>• Ripley y Placa: patrón nocturno del deck ya era ~0; se descarta fuga de madrugada.</a:t>
+            </a:r>
+          </a:p>
+          <a:p>
+            <a:pPr algn="l">
+              <a:spcAft>
+                <a:spcPts val="200"/>
+              </a:spcAft>
+            </a:pPr>
+            <a:r>
+              <a:rPr sz="1100" b="0">
+                <a:solidFill>
+                  <a:srgbClr val="0D3B66"/>
+                </a:solidFill>
+                <a:latin typeface="Calibri"/>
+              </a:rPr>
+              <a:t>• Falabella: las noches desde el 12/08 (8–13 m³ en 0–6 h) NO se descartan; el punto recién entra en medición.</a:t>
             </a:r>
           </a:p>
         </p:txBody>
@@ -8503,7 +8551,7 @@
                 </a:solidFill>
                 <a:latin typeface="Calibri"/>
               </a:rPr>
-              <a:t>Agosto 1–14: 2.773,8 m³  (198,1 m³/día)</a:t>
+              <a:t>Agosto 1–14: 2.901,3 m³  (207,2 m³/día)</a:t>
             </a:r>
           </a:p>
           <a:p>
@@ -8519,7 +8567,7 @@
                 </a:solidFill>
                 <a:latin typeface="Calibri"/>
               </a:rPr>
-              <a:t>Proyección agosto: 6.142,1 m³</a:t>
+              <a:t>Proyección agosto: 6.424,3 m³</a:t>
             </a:r>
           </a:p>
           <a:p>
@@ -8535,7 +8583,7 @@
                 </a:solidFill>
                 <a:latin typeface="Calibri"/>
               </a:rPr>
-              <a:t>Mayor aporte: Matriz Principal — jun 3.930,8 / jul 5.993,6 / ago 2.730,1 m³</a:t>
+              <a:t>Mayor aporte: Matriz Principal — jun 3.930,8 / jul 5.993,6 / ago 2.854,9 m³</a:t>
             </a:r>
           </a:p>
           <a:p>
@@ -8551,7 +8599,7 @@
                 </a:solidFill>
                 <a:latin typeface="Calibri"/>
               </a:rPr>
-              <a:t>Variación m³/día: jul vs jun 45%  ·  ago vs jul 1%</a:t>
+              <a:t>Variación m³/día: jul vs jun 45%  ·  ago vs jul 6%</a:t>
             </a:r>
           </a:p>
         </p:txBody>
@@ -9558,7 +9606,7 @@
                 </a:solidFill>
                 <a:latin typeface="Calibri"/>
               </a:rPr>
-              <a:t>Agosto 1–14: 2.099,5 m³  (150 m³/día)</a:t>
+              <a:t>Agosto 1–14: 2.180,7 m³  (155,8 m³/día)</a:t>
             </a:r>
           </a:p>
           <a:p>
@@ -9574,7 +9622,7 @@
                 </a:solidFill>
                 <a:latin typeface="Calibri"/>
               </a:rPr>
-              <a:t>Proyección agosto: 4.649 m³</a:t>
+              <a:t>Proyección agosto: 4.828,7 m³</a:t>
             </a:r>
           </a:p>
           <a:p>
@@ -9590,7 +9638,7 @@
                 </a:solidFill>
                 <a:latin typeface="Calibri"/>
               </a:rPr>
-              <a:t>Mayor aporte: San Ignacio 500 — jun 1.415,3 / jul 4.066,5 / ago 1.557 m³</a:t>
+              <a:t>Mayor aporte: San Ignacio 500 — jun 1.415,3 / jul 4.066,5 / ago 1.614 m³</a:t>
             </a:r>
           </a:p>
           <a:p>
@@ -9606,7 +9654,7 @@
                 </a:solidFill>
                 <a:latin typeface="Calibri"/>
               </a:rPr>
-              <a:t>Variación m³/día: jul vs jun 181%  ·  ago vs jul -9%</a:t>
+              <a:t>Variación m³/día: jul vs jun 181%  ·  ago vs jul -6%</a:t>
             </a:r>
           </a:p>
         </p:txBody>
@@ -10597,7 +10645,7 @@
                 </a:solidFill>
                 <a:latin typeface="Calibri"/>
               </a:rPr>
-              <a:t>Agosto 1–14: 968,3 m³  (69,2 m³/día)</a:t>
+              <a:t>Agosto 1–14: 1.004,8 m³  (71,8 m³/día)</a:t>
             </a:r>
           </a:p>
           <a:p>
@@ -10613,7 +10661,7 @@
                 </a:solidFill>
                 <a:latin typeface="Calibri"/>
               </a:rPr>
-              <a:t>Proyección agosto: 2.144,1 m³</a:t>
+              <a:t>Proyección agosto: 2.225 m³</a:t>
             </a:r>
           </a:p>
           <a:p>
@@ -10629,7 +10677,7 @@
                 </a:solidFill>
                 <a:latin typeface="Calibri"/>
               </a:rPr>
-              <a:t>Mayor aporte: Matriz principal 1°piso — jun 1.651,6 / jul 1.724,2 / ago 785,5 m³</a:t>
+              <a:t>Mayor aporte: Matriz principal 1°piso — jun 1.651,6 / jul 1.724,2 / ago 818,8 m³</a:t>
             </a:r>
           </a:p>
           <a:p>
@@ -10645,7 +10693,7 @@
                 </a:solidFill>
                 <a:latin typeface="Calibri"/>
               </a:rPr>
-              <a:t>Variación m³/día: jul vs jun 8%  ·  ago vs jul -10%</a:t>
+              <a:t>Variación m³/día: jul vs jun 8%  ·  ago vs jul -6%</a:t>
             </a:r>
           </a:p>
         </p:txBody>
@@ -10808,7 +10856,7 @@
                 </a:solidFill>
                 <a:latin typeface="Calibri"/>
               </a:rPr>
-              <a:t>• Matriz 11: jun 1.651,6 / jul 1.724,2 / ago 785,5 m³ (~55 m³/día, estable).</a:t>
+              <a:t>• Matriz 11: jun 1.651,6 / jul 1.724,2 / ago 818,8 m³ (~55 m³/día, estable).</a:t>
             </a:r>
           </a:p>
           <a:p>
@@ -11652,7 +11700,7 @@
                 </a:solidFill>
                 <a:latin typeface="Calibri"/>
               </a:rPr>
-              <a:t>Agosto 1–14: 294 m³  (21 m³/día)</a:t>
+              <a:t>Agosto 1–14: 304,3 m³  (21,7 m³/día)</a:t>
             </a:r>
           </a:p>
           <a:p>
@@ -11668,7 +11716,7 @@
                 </a:solidFill>
                 <a:latin typeface="Calibri"/>
               </a:rPr>
-              <a:t>Proyección agosto: 651,1 m³</a:t>
+              <a:t>Proyección agosto: 673,9 m³</a:t>
             </a:r>
           </a:p>
           <a:p>
@@ -11684,7 +11732,7 @@
                 </a:solidFill>
                 <a:latin typeface="Calibri"/>
               </a:rPr>
-              <a:t>Mayor aporte: CUR Anillo Sur — jun 342,3 / jul 331,9 / ago 154,2 m³</a:t>
+              <a:t>Mayor aporte: CUR Anillo Sur — jun 342,3 / jul 331,9 / ago 159,2 m³</a:t>
             </a:r>
           </a:p>
           <a:p>
@@ -11700,7 +11748,7 @@
                 </a:solidFill>
                 <a:latin typeface="Calibri"/>
               </a:rPr>
-              <a:t>Variación m³/día: jul vs jun -10%  ·  ago vs jul 5%</a:t>
+              <a:t>Variación m³/día: jul vs jun -10%  ·  ago vs jul 9%</a:t>
             </a:r>
           </a:p>
         </p:txBody>
@@ -11863,7 +11911,7 @@
                 </a:solidFill>
                 <a:latin typeface="Calibri"/>
               </a:rPr>
-              <a:t>• Volumen conjunto estable: jun 663,8 / jul 618,5 / ago 294 m³ (~20–22 m³/día).</a:t>
+              <a:t>• Volumen conjunto estable: jun 663,8 / jul 618,5 / ago 304,3 m³ (~20–22 m³/día).</a:t>
             </a:r>
           </a:p>
           <a:p>
@@ -12819,7 +12867,7 @@
                 </a:solidFill>
                 <a:latin typeface="Calibri"/>
               </a:rPr>
-              <a:t>Agosto 1–14: 17.265,4 m³  (1.233,2 m³/día)</a:t>
+              <a:t>Agosto 1–14: 17.879,2 m³  (1.277,1 m³/día)</a:t>
             </a:r>
           </a:p>
           <a:p>
@@ -12835,7 +12883,7 @@
                 </a:solidFill>
                 <a:latin typeface="Calibri"/>
               </a:rPr>
-              <a:t>Proyección agosto: 38.230,5 m³</a:t>
+              <a:t>Proyección agosto: 39.589,7 m³</a:t>
             </a:r>
           </a:p>
           <a:p>
@@ -12867,7 +12915,7 @@
                 </a:solidFill>
                 <a:latin typeface="Calibri"/>
               </a:rPr>
-              <a:t>Mayor cabecera: Sala de Bomba Sandia Antigua — jun 8.532,6 / jul 13.661,2 / ago 7.264,4 m³</a:t>
+              <a:t>Mayor cabecera: Sala de Bomba Sandia Antigua — jun 8.532,6 / jul 13.661,2 / ago 7.497,6 m³</a:t>
             </a:r>
           </a:p>
           <a:p>
@@ -12883,7 +12931,7 @@
                 </a:solidFill>
                 <a:latin typeface="Calibri"/>
               </a:rPr>
-              <a:t>Variación m³/día: jul vs jun 44%  ·  ago vs jul 22%</a:t>
+              <a:t>Variación m³/día: jul vs jun 44%  ·  ago vs jul 27%</a:t>
             </a:r>
           </a:p>
         </p:txBody>
@@ -13062,7 +13110,7 @@
                 </a:solidFill>
                 <a:latin typeface="Calibri"/>
               </a:rPr>
-              <a:t>• Consumo de cabecera (sin doble conteo): jun 20.927,5 / jul 31.239 / ago 17.265,4 m³.</a:t>
+              <a:t>• Consumo de cabecera (sin doble conteo): jun 20.927,5 / jul 31.239 / ago 17.879,2 m³.</a:t>
             </a:r>
           </a:p>
           <a:p>

</xml_diff>

<commit_message>
Clarify MAE point 5: night with control is not a leak
Replace the ambiguous DESCARTADO label with 'noche con control:
no se lee como fuga' so the control itself is not read as discarded.

Co-authored-by: anibaloperacionesWes <anibaloperacionesWes@users.noreply.github.com>
</commit_message>
<xml_diff>
--- a/reports/Parque_Arauco/TMP_7MALLS/entrega_diego_anibal/Fichas_ejecutivas_Parque_Arauco_20260814.pptx
+++ b/reports/Parque_Arauco/TMP_7MALLS/entrega_diego_anibal/Fichas_ejecutivas_Parque_Arauco_20260814.pptx
@@ -3292,7 +3292,7 @@
                 </a:solidFill>
                 <a:latin typeface="Calibri"/>
               </a:rPr>
-              <a:t>5 variables por mall  ·  controles nocturnos descartados del análisis de fugas</a:t>
+              <a:t>5 variables por mall  ·  si hay control nocturno, esa madrugada no se lee como fuga</a:t>
             </a:r>
           </a:p>
           <a:p>
@@ -3875,7 +3875,7 @@
                         </a:defRPr>
                       </a:pPr>
                       <a:r>
-                        <a:t>Noches Norte/Pizza/Sur descartadas. Norte: alza diurna ago.</a:t>
+                        <a:t>Norte/Pizza/Sur: noche con control, no es fuga. Norte: alza diurna ago.</a:t>
                       </a:r>
                     </a:p>
                   </a:txBody>
@@ -5726,7 +5726,7 @@
                 </a:solidFill>
                 <a:latin typeface="Calibri"/>
               </a:rPr>
-              <a:t>5. Controles nocturnos (descartados)</a:t>
+              <a:t>5. Noche con control: no se lee como fuga</a:t>
             </a:r>
           </a:p>
         </p:txBody>
@@ -5765,7 +5765,7 @@
                 </a:solidFill>
                 <a:latin typeface="Calibri"/>
               </a:rPr>
-              <a:t>San Ignacio 500 desde 16/07 · Pizza Hut desde 01/07 · Estanque Norte desde 05/08 · Estanque Sur: corte on/off de mantención nocturna. Verificados con perfil 0–6 h.</a:t>
+              <a:t>Si el punto tiene control on/off (o corte de mantención), el caudal de madrugada no se interpreta como fuga. San Ignacio 500 desde 16/07 · Pizza Hut desde 01/07 · Estanque Norte desde 05/08 · Estanque Sur: corte de mantención nocturna.</a:t>
             </a:r>
           </a:p>
         </p:txBody>
@@ -6540,7 +6540,7 @@
                 </a:solidFill>
                 <a:latin typeface="Calibri"/>
               </a:rPr>
-              <a:t>• Pizza Hut: control nocturno desde 01/07 funciona (noche ~0 m³ el 10/08). El alza de julio (23,8 → 37,7 m³/día) es diurna; agosto baja a 14,1 m³/día. Noche descartada.</a:t>
+              <a:t>• Pizza Hut: control nocturno desde 01/07 funciona (noche ~0 m³ el 10/08). El alza de julio (23,8 → 37,7 m³/día) es diurna; agosto baja a 14,1 m³/día. Esa noche no se lee como fuga.</a:t>
             </a:r>
           </a:p>
           <a:p>
@@ -6829,7 +6829,7 @@
                 </a:solidFill>
                 <a:latin typeface="Calibri"/>
               </a:rPr>
-              <a:t>5. CONTROLES NOCTURNOS — DESCARTADOS DEL ANÁLISIS DE FUGAS</a:t>
+              <a:t>5. NOCHE CON CONTROL: NO SE LEE COMO FUGA</a:t>
             </a:r>
           </a:p>
         </p:txBody>
@@ -6868,7 +6868,7 @@
                 </a:solidFill>
                 <a:latin typeface="Calibri"/>
               </a:rPr>
-              <a:t>• Estanque Sur (000025-19): corte on/off a cargo de personal de mantención nocturno — DESCARTADO.</a:t>
+              <a:t>• Estanque Sur (000025-19): corte on/off de mantención nocturna. La madrugada NO se lee como fuga.</a:t>
             </a:r>
           </a:p>
           <a:p>
@@ -6884,7 +6884,7 @@
                 </a:solidFill>
                 <a:latin typeface="Calibri"/>
               </a:rPr>
-              <a:t>• Pizza Hut (000025-07): control nocturno desde 01/07/2026 (00:00–06:00) — DESCARTADO. Verificado 10/08: 0 m³ en 0–6 h.</a:t>
+              <a:t>• Pizza Hut (000025-07): control 00:00–06:00 desde 01/07. Noche OK (10/08: 0 m³). No se lee como fuga.</a:t>
             </a:r>
           </a:p>
           <a:p>
@@ -6900,7 +6900,7 @@
                 </a:solidFill>
                 <a:latin typeface="Calibri"/>
               </a:rPr>
-              <a:t>• Estanque Norte (000025-01): control nocturno desde 05/08/2026 — DESCARTADO.</a:t>
+              <a:t>• Estanque Norte (000025-01): control desde 05/08. La madrugada NO se lee como fuga (el alza de agosto es diurna).</a:t>
             </a:r>
           </a:p>
           <a:p>
@@ -6916,7 +6916,7 @@
                 </a:solidFill>
                 <a:latin typeface="Calibri"/>
               </a:rPr>
-              <a:t>• Baños Públicos: control instalado sin funcionamiento; noches ya ~0 — no se interpreta como fuga.</a:t>
+              <a:t>• Baños Públicos: control instalado sin uso; noches ya ~0. Tampoco se interpreta como fuga.</a:t>
             </a:r>
           </a:p>
         </p:txBody>
@@ -7980,7 +7980,7 @@
                 </a:solidFill>
                 <a:latin typeface="Calibri"/>
               </a:rPr>
-              <a:t>5. CONTROLES NOCTURNOS — DESCARTADOS DEL ANÁLISIS DE FUGAS</a:t>
+              <a:t>5. NOCHE CON CONTROL: NO SE LEE COMO FUGA</a:t>
             </a:r>
           </a:p>
         </p:txBody>
@@ -9051,7 +9051,7 @@
                 </a:solidFill>
                 <a:latin typeface="Calibri"/>
               </a:rPr>
-              <a:t>5. CONTROLES NOCTURNOS — DESCARTADOS DEL ANÁLISIS DE FUGAS</a:t>
+              <a:t>5. NOCHE CON CONTROL: NO SE LEE COMO FUGA</a:t>
             </a:r>
           </a:p>
         </p:txBody>
@@ -10090,7 +10090,7 @@
                 </a:solidFill>
                 <a:latin typeface="Calibri"/>
               </a:rPr>
-              <a:t>5. CONTROLES NOCTURNOS — DESCARTADOS DEL ANÁLISIS DE FUGAS</a:t>
+              <a:t>5. NOCHE CON CONTROL: NO SE LEE COMO FUGA</a:t>
             </a:r>
           </a:p>
         </p:txBody>
@@ -10129,7 +10129,7 @@
                 </a:solidFill>
                 <a:latin typeface="Calibri"/>
               </a:rPr>
-              <a:t>• San Ignacio 500 (000025-18): control nocturno desde 16/07/2026 — DESCARTADO (verificado: noche 42 → 2 m³).</a:t>
+              <a:t>• San Ignacio 500 (000025-18): control desde 16/07. Noche 42 → 2 m³. Esa madrugada NO se lee como fuga.</a:t>
             </a:r>
           </a:p>
           <a:p>
@@ -10145,7 +10145,7 @@
                 </a:solidFill>
                 <a:latin typeface="Calibri"/>
               </a:rPr>
-              <a:t>• San Ignacio 300: sin control. No se descarta.</a:t>
+              <a:t>• San Ignacio 300: sin control. La noche SÍ entra al análisis (el 10/08 fue ~51% nocturna).</a:t>
             </a:r>
           </a:p>
         </p:txBody>
@@ -11145,7 +11145,7 @@
                 </a:solidFill>
                 <a:latin typeface="Calibri"/>
               </a:rPr>
-              <a:t>5. CONTROLES NOCTURNOS — DESCARTADOS DEL ANÁLISIS DE FUGAS</a:t>
+              <a:t>5. NOCHE CON CONTROL: NO SE LEE COMO FUGA</a:t>
             </a:r>
           </a:p>
         </p:txBody>
@@ -12184,7 +12184,7 @@
                 </a:solidFill>
                 <a:latin typeface="Calibri"/>
               </a:rPr>
-              <a:t>5. CONTROLES NOCTURNOS — DESCARTADOS DEL ANÁLISIS DE FUGAS</a:t>
+              <a:t>5. NOCHE CON CONTROL: NO SE LEE COMO FUGA</a:t>
             </a:r>
           </a:p>
         </p:txBody>
@@ -13383,7 +13383,7 @@
                 </a:solidFill>
                 <a:latin typeface="Calibri"/>
               </a:rPr>
-              <a:t>5. CONTROLES NOCTURNOS — DESCARTADOS DEL ANÁLISIS DE FUGAS</a:t>
+              <a:t>5. NOCHE CON CONTROL: NO SE LEE COMO FUGA</a:t>
             </a:r>
           </a:p>
         </p:txBody>

</xml_diff>